<commit_message>
Region statistics button (CoStar PDF) in acquisition block; deck v3: real LEMONICA logo, bold clickable source link
</commit_message>
<xml_diff>
--- a/presentation/Hollywood_District_CoStar_3slides.pptx
+++ b/presentation/Hollywood_District_CoStar_3slides.pptx
@@ -3225,7 +3225,7 @@
                 </a:solidFill>
                 <a:latin typeface="Georgia"/>
               </a:rPr>
-              <a:t>7–9% населения</a:t>
+              <a:t>90 000 жителей</a:t>
             </a:r>
             <a:r>
               <a:rPr sz="4000" b="1" i="0">
@@ -3234,7 +3234,7 @@
                 </a:solidFill>
                 <a:latin typeface="Georgia"/>
               </a:rPr>
-              <a:t> к 2030 году</a:t>
+              <a:t> за 5 лет</a:t>
             </a:r>
           </a:p>
         </p:txBody>
@@ -3273,7 +3273,7 @@
                 </a:solidFill>
                 <a:latin typeface="Arial"/>
               </a:rPr>
-              <a:t>Население в радиусе ресторана (CoStar, прогноз 2025 → 2030)</a:t>
+              <a:t>Радиус 10 миль от ресторана — прогноз CoStar, 2025 → 2030</a:t>
             </a:r>
           </a:p>
         </p:txBody>
@@ -3286,8 +3286,8 @@
         </p:nvSpPr>
         <p:spPr>
           <a:xfrm>
-            <a:off x="1325880" y="5023378"/>
-            <a:ext cx="566928" cy="188701"/>
+            <a:off x="1645920" y="2882029"/>
+            <a:ext cx="1371600" cy="2330050"/>
           </a:xfrm>
           <a:prstGeom prst="rect">
             <a:avLst/>
@@ -3324,14 +3324,92 @@
       </p:sp>
       <p:sp>
         <p:nvSpPr>
-          <p:cNvPr id="7" name="Rectangle 6"/>
+          <p:cNvPr id="7" name="TextBox 6"/>
+          <p:cNvSpPr txBox="1"/>
+          <p:nvPr/>
+        </p:nvSpPr>
+        <p:spPr>
+          <a:xfrm>
+            <a:off x="868680" y="2497981"/>
+            <a:ext cx="2926080" cy="365760"/>
+          </a:xfrm>
+          <a:prstGeom prst="rect">
+            <a:avLst/>
+          </a:prstGeom>
+          <a:noFill/>
+        </p:spPr>
+        <p:txBody>
+          <a:bodyPr wrap="square" anchor="t" lIns="0" rIns="0" tIns="0" bIns="0">
+            <a:spAutoFit/>
+          </a:bodyPr>
+          <a:lstStyle/>
+          <a:p>
+            <a:pPr algn="ctr">
+              <a:lnSpc>
+                <a:spcPct val="100000"/>
+              </a:lnSpc>
+            </a:pPr>
+            <a:r>
+              <a:rPr sz="2200" b="1" i="0">
+                <a:solidFill>
+                  <a:srgbClr val="9B9786"/>
+                </a:solidFill>
+                <a:latin typeface="Georgia"/>
+              </a:rPr>
+              <a:t>1,21 млн</a:t>
+            </a:r>
+          </a:p>
+        </p:txBody>
+      </p:sp>
+      <p:sp>
+        <p:nvSpPr>
+          <p:cNvPr id="8" name="TextBox 7"/>
+          <p:cNvSpPr txBox="1"/>
+          <p:nvPr/>
+        </p:nvSpPr>
+        <p:spPr>
+          <a:xfrm>
+            <a:off x="868680" y="5532120"/>
+            <a:ext cx="2926080" cy="274320"/>
+          </a:xfrm>
+          <a:prstGeom prst="rect">
+            <a:avLst/>
+          </a:prstGeom>
+          <a:noFill/>
+        </p:spPr>
+        <p:txBody>
+          <a:bodyPr wrap="square" anchor="t" lIns="0" rIns="0" tIns="0" bIns="0">
+            <a:spAutoFit/>
+          </a:bodyPr>
+          <a:lstStyle/>
+          <a:p>
+            <a:pPr algn="ctr">
+              <a:lnSpc>
+                <a:spcPct val="100000"/>
+              </a:lnSpc>
+            </a:pPr>
+            <a:r>
+              <a:rPr sz="1300" b="1" i="0">
+                <a:solidFill>
+                  <a:srgbClr val="FFFDF6"/>
+                </a:solidFill>
+                <a:latin typeface="Arial"/>
+              </a:rPr>
+              <a:t>2025</a:t>
+            </a:r>
+          </a:p>
+        </p:txBody>
+      </p:sp>
+      <p:sp>
+        <p:nvSpPr>
+          <p:cNvPr id="9" name="Rectangle 8"/>
           <p:cNvSpPr/>
           <p:nvPr/>
         </p:nvSpPr>
         <p:spPr>
           <a:xfrm>
-            <a:off x="1965960" y="5009813"/>
-            <a:ext cx="566928" cy="202266"/>
+            <a:off x="4572000" y="2706872"/>
+            <a:ext cx="1371600" cy="2505207"/>
           </a:xfrm>
           <a:prstGeom prst="rect">
             <a:avLst/>
@@ -3368,14 +3446,14 @@
       </p:sp>
       <p:sp>
         <p:nvSpPr>
-          <p:cNvPr id="8" name="TextBox 7"/>
+          <p:cNvPr id="10" name="TextBox 9"/>
           <p:cNvSpPr txBox="1"/>
           <p:nvPr/>
         </p:nvSpPr>
         <p:spPr>
           <a:xfrm>
-            <a:off x="1143000" y="4712482"/>
-            <a:ext cx="1005840" cy="274320"/>
+            <a:off x="3794760" y="2322824"/>
+            <a:ext cx="2926080" cy="365760"/>
           </a:xfrm>
           <a:prstGeom prst="rect">
             <a:avLst/>
@@ -3394,27 +3472,27 @@
               </a:lnSpc>
             </a:pPr>
             <a:r>
-              <a:rPr sz="1050" b="0" i="0">
-                <a:solidFill>
-                  <a:srgbClr val="9B9786"/>
-                </a:solidFill>
-                <a:latin typeface="Arial"/>
-              </a:rPr>
-              <a:t>94 тыс.</a:t>
-            </a:r>
-          </a:p>
-        </p:txBody>
-      </p:sp>
-      <p:sp>
-        <p:nvSpPr>
-          <p:cNvPr id="9" name="TextBox 8"/>
+              <a:rPr sz="2200" b="1" i="0">
+                <a:solidFill>
+                  <a:srgbClr val="ECC558"/>
+                </a:solidFill>
+                <a:latin typeface="Georgia"/>
+              </a:rPr>
+              <a:t>1,30 млн</a:t>
+            </a:r>
+          </a:p>
+        </p:txBody>
+      </p:sp>
+      <p:sp>
+        <p:nvSpPr>
+          <p:cNvPr id="11" name="TextBox 10"/>
           <p:cNvSpPr txBox="1"/>
           <p:nvPr/>
         </p:nvSpPr>
         <p:spPr>
           <a:xfrm>
-            <a:off x="1783080" y="4698917"/>
-            <a:ext cx="1005840" cy="274320"/>
+            <a:off x="3794760" y="5532120"/>
+            <a:ext cx="2926080" cy="274320"/>
           </a:xfrm>
           <a:prstGeom prst="rect">
             <a:avLst/>
@@ -3433,27 +3511,27 @@
               </a:lnSpc>
             </a:pPr>
             <a:r>
-              <a:rPr sz="1050" b="1" i="0">
-                <a:solidFill>
-                  <a:srgbClr val="ECC558"/>
+              <a:rPr sz="1300" b="1" i="0">
+                <a:solidFill>
+                  <a:srgbClr val="FFFDF6"/>
                 </a:solidFill>
                 <a:latin typeface="Arial"/>
               </a:rPr>
-              <a:t>101 тыс.</a:t>
-            </a:r>
-          </a:p>
-        </p:txBody>
-      </p:sp>
-      <p:sp>
-        <p:nvSpPr>
-          <p:cNvPr id="10" name="TextBox 9"/>
+              <a:t>2030 (прогноз)</a:t>
+            </a:r>
+          </a:p>
+        </p:txBody>
+      </p:sp>
+      <p:sp>
+        <p:nvSpPr>
+          <p:cNvPr id="12" name="TextBox 11"/>
           <p:cNvSpPr txBox="1"/>
           <p:nvPr/>
         </p:nvSpPr>
         <p:spPr>
           <a:xfrm>
-            <a:off x="1051560" y="5513832"/>
-            <a:ext cx="1859280" cy="274320"/>
+            <a:off x="1188720" y="2926080"/>
+            <a:ext cx="5029200" cy="548640"/>
           </a:xfrm>
           <a:prstGeom prst="rect">
             <a:avLst/>
@@ -3466,81 +3544,46 @@
           </a:bodyPr>
           <a:lstStyle/>
           <a:p>
-            <a:pPr algn="ctr">
+            <a:pPr algn="l">
               <a:lnSpc>
                 <a:spcPct val="100000"/>
               </a:lnSpc>
             </a:pPr>
             <a:r>
-              <a:rPr sz="1300" b="1" i="0">
-                <a:solidFill>
-                  <a:srgbClr val="FFFDF6"/>
-                </a:solidFill>
-                <a:latin typeface="Arial"/>
-              </a:rPr>
-              <a:t>2 мили</a:t>
-            </a:r>
-          </a:p>
-        </p:txBody>
-      </p:sp>
-      <p:sp>
-        <p:nvSpPr>
-          <p:cNvPr id="11" name="TextBox 10"/>
-          <p:cNvSpPr txBox="1"/>
-          <p:nvPr/>
-        </p:nvSpPr>
-        <p:spPr>
-          <a:xfrm>
-            <a:off x="1051560" y="5916168"/>
-            <a:ext cx="1859280" cy="274320"/>
-          </a:xfrm>
-          <a:prstGeom prst="rect">
-            <a:avLst/>
-          </a:prstGeom>
-          <a:noFill/>
-        </p:spPr>
-        <p:txBody>
-          <a:bodyPr wrap="square" anchor="t" lIns="0" rIns="0" tIns="0" bIns="0">
-            <a:spAutoFit/>
-          </a:bodyPr>
-          <a:lstStyle/>
-          <a:p>
-            <a:pPr algn="ctr">
-              <a:lnSpc>
-                <a:spcPct val="100000"/>
-              </a:lnSpc>
-            </a:pPr>
-            <a:r>
-              <a:rPr sz="1300" b="1" i="0">
+              <a:rPr sz="2000" b="1" i="0">
                 <a:solidFill>
                   <a:srgbClr val="E3B62C"/>
                 </a:solidFill>
                 <a:latin typeface="Georgia"/>
               </a:rPr>
-              <a:t>+7,2%</a:t>
-            </a:r>
-          </a:p>
-        </p:txBody>
-      </p:sp>
-      <p:sp>
-        <p:nvSpPr>
-          <p:cNvPr id="12" name="Rectangle 11"/>
+              <a:t>+7,5% за 5 лет  ·  +90 736 человек</a:t>
+            </a:r>
+          </a:p>
+        </p:txBody>
+      </p:sp>
+      <p:sp>
+        <p:nvSpPr>
+          <p:cNvPr id="13" name="Rounded Rectangle 12"/>
           <p:cNvSpPr/>
           <p:nvPr/>
         </p:nvSpPr>
         <p:spPr>
           <a:xfrm>
-            <a:off x="3642360" y="4444434"/>
-            <a:ext cx="566928" cy="767645"/>
-          </a:xfrm>
-          <a:prstGeom prst="rect">
-            <a:avLst/>
+            <a:off x="8275320" y="2514600"/>
+            <a:ext cx="3383280" cy="1417320"/>
+          </a:xfrm>
+          <a:prstGeom prst="roundRect">
+            <a:avLst>
+              <a:gd name="adj" fmla="val 7000"/>
+            </a:avLst>
           </a:prstGeom>
           <a:solidFill>
-            <a:srgbClr val="4A4A30"/>
+            <a:srgbClr val="1E1E12"/>
           </a:solidFill>
-          <a:ln>
-            <a:noFill/>
+          <a:ln w="12700">
+            <a:solidFill>
+              <a:srgbClr val="3A3A22"/>
+            </a:solidFill>
           </a:ln>
           <a:effectLst/>
         </p:spPr>
@@ -3568,23 +3611,104 @@
       </p:sp>
       <p:sp>
         <p:nvSpPr>
-          <p:cNvPr id="13" name="Rectangle 12"/>
-          <p:cNvSpPr/>
+          <p:cNvPr id="14" name="TextBox 13"/>
+          <p:cNvSpPr txBox="1"/>
           <p:nvPr/>
         </p:nvSpPr>
         <p:spPr>
           <a:xfrm>
-            <a:off x="4282440" y="4377974"/>
-            <a:ext cx="566928" cy="834105"/>
+            <a:off x="8531352" y="2734056"/>
+            <a:ext cx="2871216" cy="905256"/>
           </a:xfrm>
           <a:prstGeom prst="rect">
             <a:avLst/>
           </a:prstGeom>
+          <a:noFill/>
+        </p:spPr>
+        <p:txBody>
+          <a:bodyPr wrap="square" anchor="t" lIns="0" rIns="0" tIns="0" bIns="0">
+            <a:spAutoFit/>
+          </a:bodyPr>
+          <a:lstStyle/>
+          <a:p>
+            <a:pPr algn="l">
+              <a:lnSpc>
+                <a:spcPct val="100000"/>
+              </a:lnSpc>
+              <a:spcAft>
+                <a:spcPts val="800"/>
+              </a:spcAft>
+            </a:pPr>
+            <a:r>
+              <a:rPr sz="2800" b="1" i="0">
+                <a:solidFill>
+                  <a:srgbClr val="E3B62C"/>
+                </a:solidFill>
+                <a:latin typeface="Georgia"/>
+              </a:rPr>
+              <a:t>1,30 млн</a:t>
+            </a:r>
+          </a:p>
+          <a:p>
+            <a:pPr algn="l">
+              <a:lnSpc>
+                <a:spcPct val="100000"/>
+              </a:lnSpc>
+              <a:spcAft>
+                <a:spcPts val="300"/>
+              </a:spcAft>
+            </a:pPr>
+            <a:r>
+              <a:rPr sz="1250" b="1" i="0">
+                <a:solidFill>
+                  <a:srgbClr val="FFFDF6"/>
+                </a:solidFill>
+                <a:latin typeface="Arial"/>
+              </a:rPr>
+              <a:t>жителей в радиусе 10 миль — 2030</a:t>
+            </a:r>
+          </a:p>
+          <a:p>
+            <a:pPr algn="l">
+              <a:lnSpc>
+                <a:spcPct val="100000"/>
+              </a:lnSpc>
+            </a:pPr>
+            <a:r>
+              <a:rPr sz="1050" b="0" i="0">
+                <a:solidFill>
+                  <a:srgbClr val="9B9786"/>
+                </a:solidFill>
+                <a:latin typeface="Arial"/>
+              </a:rPr>
+              <a:t>сегодня 1,21 млн</a:t>
+            </a:r>
+          </a:p>
+        </p:txBody>
+      </p:sp>
+      <p:sp>
+        <p:nvSpPr>
+          <p:cNvPr id="15" name="Rounded Rectangle 14"/>
+          <p:cNvSpPr/>
+          <p:nvPr/>
+        </p:nvSpPr>
+        <p:spPr>
+          <a:xfrm>
+            <a:off x="8275320" y="4069080"/>
+            <a:ext cx="3383280" cy="1417320"/>
+          </a:xfrm>
+          <a:prstGeom prst="roundRect">
+            <a:avLst>
+              <a:gd name="adj" fmla="val 7000"/>
+            </a:avLst>
+          </a:prstGeom>
           <a:solidFill>
-            <a:srgbClr val="E3B62C"/>
+            <a:srgbClr val="1E1E12"/>
           </a:solidFill>
-          <a:ln>
-            <a:noFill/>
+          <a:ln w="12700">
+            <a:solidFill>
+              <a:srgbClr val="3A3A22"/>
+            </a:solidFill>
           </a:ln>
           <a:effectLst/>
         </p:spPr>
@@ -3612,14 +3736,14 @@
       </p:sp>
       <p:sp>
         <p:nvSpPr>
-          <p:cNvPr id="14" name="TextBox 13"/>
+          <p:cNvPr id="16" name="TextBox 15"/>
           <p:cNvSpPr txBox="1"/>
           <p:nvPr/>
         </p:nvSpPr>
         <p:spPr>
           <a:xfrm>
-            <a:off x="3459480" y="4133538"/>
-            <a:ext cx="1005840" cy="274320"/>
+            <a:off x="8531352" y="4288536"/>
+            <a:ext cx="2871216" cy="905256"/>
           </a:xfrm>
           <a:prstGeom prst="rect">
             <a:avLst/>
@@ -3632,405 +3756,43 @@
           </a:bodyPr>
           <a:lstStyle/>
           <a:p>
-            <a:pPr algn="ctr">
+            <a:pPr algn="l">
               <a:lnSpc>
                 <a:spcPct val="100000"/>
               </a:lnSpc>
+              <a:spcAft>
+                <a:spcPts val="800"/>
+              </a:spcAft>
             </a:pPr>
             <a:r>
-              <a:rPr sz="1050" b="0" i="0">
-                <a:solidFill>
-                  <a:srgbClr val="9B9786"/>
-                </a:solidFill>
-                <a:latin typeface="Arial"/>
-              </a:rPr>
-              <a:t>383 тыс.</a:t>
-            </a:r>
-          </a:p>
-        </p:txBody>
-      </p:sp>
-      <p:sp>
-        <p:nvSpPr>
-          <p:cNvPr id="15" name="TextBox 14"/>
-          <p:cNvSpPr txBox="1"/>
-          <p:nvPr/>
-        </p:nvSpPr>
-        <p:spPr>
-          <a:xfrm>
-            <a:off x="4099560" y="4067078"/>
-            <a:ext cx="1005840" cy="274320"/>
-          </a:xfrm>
-          <a:prstGeom prst="rect">
-            <a:avLst/>
-          </a:prstGeom>
-          <a:noFill/>
-        </p:spPr>
-        <p:txBody>
-          <a:bodyPr wrap="square" anchor="t" lIns="0" rIns="0" tIns="0" bIns="0">
-            <a:spAutoFit/>
-          </a:bodyPr>
-          <a:lstStyle/>
-          <a:p>
-            <a:pPr algn="ctr">
+              <a:rPr sz="2800" b="1" i="0">
+                <a:solidFill>
+                  <a:srgbClr val="E3B62C"/>
+                </a:solidFill>
+                <a:latin typeface="Georgia"/>
+              </a:rPr>
+              <a:t>463 898</a:t>
+            </a:r>
+          </a:p>
+          <a:p>
+            <a:pPr algn="l">
               <a:lnSpc>
                 <a:spcPct val="100000"/>
               </a:lnSpc>
+              <a:spcAft>
+                <a:spcPts val="300"/>
+              </a:spcAft>
             </a:pPr>
             <a:r>
-              <a:rPr sz="1050" b="1" i="0">
-                <a:solidFill>
-                  <a:srgbClr val="ECC558"/>
+              <a:rPr sz="1250" b="1" i="0">
+                <a:solidFill>
+                  <a:srgbClr val="FFFDF6"/>
                 </a:solidFill>
                 <a:latin typeface="Arial"/>
               </a:rPr>
-              <a:t>416 тыс.</a:t>
-            </a:r>
-          </a:p>
-        </p:txBody>
-      </p:sp>
-      <p:sp>
-        <p:nvSpPr>
-          <p:cNvPr id="16" name="TextBox 15"/>
-          <p:cNvSpPr txBox="1"/>
-          <p:nvPr/>
-        </p:nvSpPr>
-        <p:spPr>
-          <a:xfrm>
-            <a:off x="3368040" y="5513832"/>
-            <a:ext cx="1859280" cy="274320"/>
-          </a:xfrm>
-          <a:prstGeom prst="rect">
-            <a:avLst/>
-          </a:prstGeom>
-          <a:noFill/>
-        </p:spPr>
-        <p:txBody>
-          <a:bodyPr wrap="square" anchor="t" lIns="0" rIns="0" tIns="0" bIns="0">
-            <a:spAutoFit/>
-          </a:bodyPr>
-          <a:lstStyle/>
-          <a:p>
-            <a:pPr algn="ctr">
-              <a:lnSpc>
-                <a:spcPct val="100000"/>
-              </a:lnSpc>
-            </a:pPr>
-            <a:r>
-              <a:rPr sz="1300" b="1" i="0">
-                <a:solidFill>
-                  <a:srgbClr val="FFFDF6"/>
-                </a:solidFill>
-                <a:latin typeface="Arial"/>
-              </a:rPr>
-              <a:t>5 миль</a:t>
-            </a:r>
-          </a:p>
-        </p:txBody>
-      </p:sp>
-      <p:sp>
-        <p:nvSpPr>
-          <p:cNvPr id="17" name="TextBox 16"/>
-          <p:cNvSpPr txBox="1"/>
-          <p:nvPr/>
-        </p:nvSpPr>
-        <p:spPr>
-          <a:xfrm>
-            <a:off x="3368040" y="5916168"/>
-            <a:ext cx="1859280" cy="274320"/>
-          </a:xfrm>
-          <a:prstGeom prst="rect">
-            <a:avLst/>
-          </a:prstGeom>
-          <a:noFill/>
-        </p:spPr>
-        <p:txBody>
-          <a:bodyPr wrap="square" anchor="t" lIns="0" rIns="0" tIns="0" bIns="0">
-            <a:spAutoFit/>
-          </a:bodyPr>
-          <a:lstStyle/>
-          <a:p>
-            <a:pPr algn="ctr">
-              <a:lnSpc>
-                <a:spcPct val="100000"/>
-              </a:lnSpc>
-            </a:pPr>
-            <a:r>
-              <a:rPr sz="1300" b="1" i="0">
-                <a:solidFill>
-                  <a:srgbClr val="E3B62C"/>
-                </a:solidFill>
-                <a:latin typeface="Georgia"/>
-              </a:rPr>
-              <a:t>+8,7%</a:t>
-            </a:r>
-          </a:p>
-        </p:txBody>
-      </p:sp>
-      <p:sp>
-        <p:nvSpPr>
-          <p:cNvPr id="18" name="Rectangle 17"/>
-          <p:cNvSpPr/>
-          <p:nvPr/>
-        </p:nvSpPr>
-        <p:spPr>
-          <a:xfrm>
-            <a:off x="5958840" y="2792411"/>
-            <a:ext cx="566928" cy="2419668"/>
-          </a:xfrm>
-          <a:prstGeom prst="rect">
-            <a:avLst/>
-          </a:prstGeom>
-          <a:solidFill>
-            <a:srgbClr val="4A4A30"/>
-          </a:solidFill>
-          <a:ln>
-            <a:noFill/>
-          </a:ln>
-          <a:effectLst/>
-        </p:spPr>
-        <p:style>
-          <a:lnRef idx="1">
-            <a:schemeClr val="accent1"/>
-          </a:lnRef>
-          <a:fillRef idx="3">
-            <a:schemeClr val="accent1"/>
-          </a:fillRef>
-          <a:effectRef idx="2">
-            <a:schemeClr val="accent1"/>
-          </a:effectRef>
-          <a:fontRef idx="minor">
-            <a:schemeClr val="lt1"/>
-          </a:fontRef>
-        </p:style>
-        <p:txBody>
-          <a:bodyPr rtlCol="0" anchor="ctr"/>
-          <a:lstStyle/>
-          <a:p>
-            <a:pPr algn="ctr"/>
-          </a:p>
-        </p:txBody>
-      </p:sp>
-      <p:sp>
-        <p:nvSpPr>
-          <p:cNvPr id="19" name="Rectangle 18"/>
-          <p:cNvSpPr/>
-          <p:nvPr/>
-        </p:nvSpPr>
-        <p:spPr>
-          <a:xfrm>
-            <a:off x="6598920" y="2610518"/>
-            <a:ext cx="566928" cy="2601561"/>
-          </a:xfrm>
-          <a:prstGeom prst="rect">
-            <a:avLst/>
-          </a:prstGeom>
-          <a:solidFill>
-            <a:srgbClr val="E3B62C"/>
-          </a:solidFill>
-          <a:ln>
-            <a:noFill/>
-          </a:ln>
-          <a:effectLst/>
-        </p:spPr>
-        <p:style>
-          <a:lnRef idx="1">
-            <a:schemeClr val="accent1"/>
-          </a:lnRef>
-          <a:fillRef idx="3">
-            <a:schemeClr val="accent1"/>
-          </a:fillRef>
-          <a:effectRef idx="2">
-            <a:schemeClr val="accent1"/>
-          </a:effectRef>
-          <a:fontRef idx="minor">
-            <a:schemeClr val="lt1"/>
-          </a:fontRef>
-        </p:style>
-        <p:txBody>
-          <a:bodyPr rtlCol="0" anchor="ctr"/>
-          <a:lstStyle/>
-          <a:p>
-            <a:pPr algn="ctr"/>
-          </a:p>
-        </p:txBody>
-      </p:sp>
-      <p:sp>
-        <p:nvSpPr>
-          <p:cNvPr id="20" name="TextBox 19"/>
-          <p:cNvSpPr txBox="1"/>
-          <p:nvPr/>
-        </p:nvSpPr>
-        <p:spPr>
-          <a:xfrm>
-            <a:off x="5775960" y="2481515"/>
-            <a:ext cx="1005840" cy="274320"/>
-          </a:xfrm>
-          <a:prstGeom prst="rect">
-            <a:avLst/>
-          </a:prstGeom>
-          <a:noFill/>
-        </p:spPr>
-        <p:txBody>
-          <a:bodyPr wrap="square" anchor="t" lIns="0" rIns="0" tIns="0" bIns="0">
-            <a:spAutoFit/>
-          </a:bodyPr>
-          <a:lstStyle/>
-          <a:p>
-            <a:pPr algn="ctr">
-              <a:lnSpc>
-                <a:spcPct val="100000"/>
-              </a:lnSpc>
-            </a:pPr>
-            <a:r>
-              <a:rPr sz="1050" b="0" i="0">
-                <a:solidFill>
-                  <a:srgbClr val="9B9786"/>
-                </a:solidFill>
-                <a:latin typeface="Arial"/>
-              </a:rPr>
-              <a:t>1.21 млн</a:t>
-            </a:r>
-          </a:p>
-        </p:txBody>
-      </p:sp>
-      <p:sp>
-        <p:nvSpPr>
-          <p:cNvPr id="21" name="TextBox 20"/>
-          <p:cNvSpPr txBox="1"/>
-          <p:nvPr/>
-        </p:nvSpPr>
-        <p:spPr>
-          <a:xfrm>
-            <a:off x="6416040" y="2299622"/>
-            <a:ext cx="1005840" cy="274320"/>
-          </a:xfrm>
-          <a:prstGeom prst="rect">
-            <a:avLst/>
-          </a:prstGeom>
-          <a:noFill/>
-        </p:spPr>
-        <p:txBody>
-          <a:bodyPr wrap="square" anchor="t" lIns="0" rIns="0" tIns="0" bIns="0">
-            <a:spAutoFit/>
-          </a:bodyPr>
-          <a:lstStyle/>
-          <a:p>
-            <a:pPr algn="ctr">
-              <a:lnSpc>
-                <a:spcPct val="100000"/>
-              </a:lnSpc>
-            </a:pPr>
-            <a:r>
-              <a:rPr sz="1050" b="1" i="0">
-                <a:solidFill>
-                  <a:srgbClr val="ECC558"/>
-                </a:solidFill>
-                <a:latin typeface="Arial"/>
-              </a:rPr>
-              <a:t>1.30 млн</a:t>
-            </a:r>
-          </a:p>
-        </p:txBody>
-      </p:sp>
-      <p:sp>
-        <p:nvSpPr>
-          <p:cNvPr id="22" name="TextBox 21"/>
-          <p:cNvSpPr txBox="1"/>
-          <p:nvPr/>
-        </p:nvSpPr>
-        <p:spPr>
-          <a:xfrm>
-            <a:off x="5684520" y="5513832"/>
-            <a:ext cx="1859280" cy="274320"/>
-          </a:xfrm>
-          <a:prstGeom prst="rect">
-            <a:avLst/>
-          </a:prstGeom>
-          <a:noFill/>
-        </p:spPr>
-        <p:txBody>
-          <a:bodyPr wrap="square" anchor="t" lIns="0" rIns="0" tIns="0" bIns="0">
-            <a:spAutoFit/>
-          </a:bodyPr>
-          <a:lstStyle/>
-          <a:p>
-            <a:pPr algn="ctr">
-              <a:lnSpc>
-                <a:spcPct val="100000"/>
-              </a:lnSpc>
-            </a:pPr>
-            <a:r>
-              <a:rPr sz="1300" b="1" i="0">
-                <a:solidFill>
-                  <a:srgbClr val="FFFDF6"/>
-                </a:solidFill>
-                <a:latin typeface="Arial"/>
-              </a:rPr>
-              <a:t>10 миль</a:t>
-            </a:r>
-          </a:p>
-        </p:txBody>
-      </p:sp>
-      <p:sp>
-        <p:nvSpPr>
-          <p:cNvPr id="23" name="TextBox 22"/>
-          <p:cNvSpPr txBox="1"/>
-          <p:nvPr/>
-        </p:nvSpPr>
-        <p:spPr>
-          <a:xfrm>
-            <a:off x="5684520" y="5916168"/>
-            <a:ext cx="1859280" cy="274320"/>
-          </a:xfrm>
-          <a:prstGeom prst="rect">
-            <a:avLst/>
-          </a:prstGeom>
-          <a:noFill/>
-        </p:spPr>
-        <p:txBody>
-          <a:bodyPr wrap="square" anchor="t" lIns="0" rIns="0" tIns="0" bIns="0">
-            <a:spAutoFit/>
-          </a:bodyPr>
-          <a:lstStyle/>
-          <a:p>
-            <a:pPr algn="ctr">
-              <a:lnSpc>
-                <a:spcPct val="100000"/>
-              </a:lnSpc>
-            </a:pPr>
-            <a:r>
-              <a:rPr sz="1300" b="1" i="0">
-                <a:solidFill>
-                  <a:srgbClr val="E3B62C"/>
-                </a:solidFill>
-                <a:latin typeface="Georgia"/>
-              </a:rPr>
-              <a:t>+7,5%</a:t>
-            </a:r>
-          </a:p>
-        </p:txBody>
-      </p:sp>
-      <p:sp>
-        <p:nvSpPr>
-          <p:cNvPr id="24" name="TextBox 23"/>
-          <p:cNvSpPr txBox="1"/>
-          <p:nvPr/>
-        </p:nvSpPr>
-        <p:spPr>
-          <a:xfrm>
-            <a:off x="1143000" y="2350008"/>
-            <a:ext cx="3200400" cy="274320"/>
-          </a:xfrm>
-          <a:prstGeom prst="rect">
-            <a:avLst/>
-          </a:prstGeom>
-          <a:noFill/>
-        </p:spPr>
-        <p:txBody>
-          <a:bodyPr wrap="square" anchor="t" lIns="0" rIns="0" tIns="0" bIns="0">
-            <a:spAutoFit/>
-          </a:bodyPr>
-          <a:lstStyle/>
+              <a:t>домохозяйств в радиусе 10 миль</a:t>
+            </a:r>
+          </a:p>
           <a:p>
             <a:pPr algn="l">
               <a:lnSpc>
@@ -4038,285 +3800,20 @@
               </a:lnSpc>
             </a:pPr>
             <a:r>
-              <a:rPr sz="1100" b="0" i="0">
-                <a:solidFill>
-                  <a:srgbClr val="4A4A30"/>
+              <a:rPr sz="1050" b="0" i="0">
+                <a:solidFill>
+                  <a:srgbClr val="9B9786"/>
                 </a:solidFill>
                 <a:latin typeface="Arial"/>
               </a:rPr>
-              <a:t>■ </a:t>
-            </a:r>
-            <a:r>
-              <a:rPr sz="1100" b="0" i="0">
-                <a:solidFill>
-                  <a:srgbClr val="9B9786"/>
-                </a:solidFill>
-                <a:latin typeface="Arial"/>
-              </a:rPr>
-              <a:t>2025    </a:t>
-            </a:r>
-            <a:r>
-              <a:rPr sz="1100" b="0" i="0">
-                <a:solidFill>
-                  <a:srgbClr val="E3B62C"/>
-                </a:solidFill>
-                <a:latin typeface="Arial"/>
-              </a:rPr>
-              <a:t>■ </a:t>
-            </a:r>
-            <a:r>
-              <a:rPr sz="1100" b="0" i="0">
-                <a:solidFill>
-                  <a:srgbClr val="9B9786"/>
-                </a:solidFill>
-                <a:latin typeface="Arial"/>
-              </a:rPr>
-              <a:t>2030 (прогноз)</a:t>
-            </a:r>
-          </a:p>
-        </p:txBody>
-      </p:sp>
-      <p:sp>
-        <p:nvSpPr>
-          <p:cNvPr id="25" name="Rounded Rectangle 24"/>
-          <p:cNvSpPr/>
-          <p:nvPr/>
-        </p:nvSpPr>
-        <p:spPr>
-          <a:xfrm>
-            <a:off x="8275320" y="2514600"/>
-            <a:ext cx="3383280" cy="1417320"/>
-          </a:xfrm>
-          <a:prstGeom prst="roundRect">
-            <a:avLst>
-              <a:gd name="adj" fmla="val 7000"/>
-            </a:avLst>
-          </a:prstGeom>
-          <a:solidFill>
-            <a:srgbClr val="1E1E12"/>
-          </a:solidFill>
-          <a:ln w="12700">
-            <a:solidFill>
-              <a:srgbClr val="3A3A22"/>
-            </a:solidFill>
-          </a:ln>
-          <a:effectLst/>
-        </p:spPr>
-        <p:style>
-          <a:lnRef idx="1">
-            <a:schemeClr val="accent1"/>
-          </a:lnRef>
-          <a:fillRef idx="3">
-            <a:schemeClr val="accent1"/>
-          </a:fillRef>
-          <a:effectRef idx="2">
-            <a:schemeClr val="accent1"/>
-          </a:effectRef>
-          <a:fontRef idx="minor">
-            <a:schemeClr val="lt1"/>
-          </a:fontRef>
-        </p:style>
-        <p:txBody>
-          <a:bodyPr rtlCol="0" anchor="ctr"/>
-          <a:lstStyle/>
-          <a:p>
-            <a:pPr algn="ctr"/>
-          </a:p>
-        </p:txBody>
-      </p:sp>
-      <p:sp>
-        <p:nvSpPr>
-          <p:cNvPr id="26" name="TextBox 25"/>
-          <p:cNvSpPr txBox="1"/>
-          <p:nvPr/>
-        </p:nvSpPr>
-        <p:spPr>
-          <a:xfrm>
-            <a:off x="8531352" y="2734056"/>
-            <a:ext cx="2871216" cy="905256"/>
-          </a:xfrm>
-          <a:prstGeom prst="rect">
-            <a:avLst/>
-          </a:prstGeom>
-          <a:noFill/>
-        </p:spPr>
-        <p:txBody>
-          <a:bodyPr wrap="square" anchor="t" lIns="0" rIns="0" tIns="0" bIns="0">
-            <a:spAutoFit/>
-          </a:bodyPr>
-          <a:lstStyle/>
-          <a:p>
-            <a:pPr algn="l">
-              <a:lnSpc>
-                <a:spcPct val="105000"/>
-              </a:lnSpc>
-            </a:pPr>
-            <a:r>
-              <a:rPr sz="3000" b="1" i="0">
-                <a:solidFill>
-                  <a:srgbClr val="E3B62C"/>
-                </a:solidFill>
-                <a:latin typeface="Georgia"/>
-              </a:rPr>
-              <a:t>1,30 млн</a:t>
-            </a:r>
-          </a:p>
-          <a:p>
-            <a:pPr algn="l">
-              <a:lnSpc>
-                <a:spcPct val="105000"/>
-              </a:lnSpc>
-            </a:pPr>
-            <a:r>
-              <a:rPr sz="1250" b="1" i="0">
-                <a:solidFill>
-                  <a:srgbClr val="FFFDF6"/>
-                </a:solidFill>
-                <a:latin typeface="Arial"/>
-              </a:rPr>
-              <a:t>жителей в радиусе 10 миль — 2030</a:t>
-            </a:r>
-          </a:p>
-          <a:p>
-            <a:pPr algn="l">
-              <a:lnSpc>
-                <a:spcPct val="105000"/>
-              </a:lnSpc>
-            </a:pPr>
-            <a:r>
-              <a:rPr sz="1050" b="0" i="0">
-                <a:solidFill>
-                  <a:srgbClr val="9B9786"/>
-                </a:solidFill>
-                <a:latin typeface="Arial"/>
-              </a:rPr>
-              <a:t>сегодня 1,21 млн</a:t>
-            </a:r>
-          </a:p>
-        </p:txBody>
-      </p:sp>
-      <p:sp>
-        <p:nvSpPr>
-          <p:cNvPr id="27" name="Rounded Rectangle 26"/>
-          <p:cNvSpPr/>
-          <p:nvPr/>
-        </p:nvSpPr>
-        <p:spPr>
-          <a:xfrm>
-            <a:off x="8275320" y="4069080"/>
-            <a:ext cx="3383280" cy="1417320"/>
-          </a:xfrm>
-          <a:prstGeom prst="roundRect">
-            <a:avLst>
-              <a:gd name="adj" fmla="val 7000"/>
-            </a:avLst>
-          </a:prstGeom>
-          <a:solidFill>
-            <a:srgbClr val="1E1E12"/>
-          </a:solidFill>
-          <a:ln w="12700">
-            <a:solidFill>
-              <a:srgbClr val="3A3A22"/>
-            </a:solidFill>
-          </a:ln>
-          <a:effectLst/>
-        </p:spPr>
-        <p:style>
-          <a:lnRef idx="1">
-            <a:schemeClr val="accent1"/>
-          </a:lnRef>
-          <a:fillRef idx="3">
-            <a:schemeClr val="accent1"/>
-          </a:fillRef>
-          <a:effectRef idx="2">
-            <a:schemeClr val="accent1"/>
-          </a:effectRef>
-          <a:fontRef idx="minor">
-            <a:schemeClr val="lt1"/>
-          </a:fontRef>
-        </p:style>
-        <p:txBody>
-          <a:bodyPr rtlCol="0" anchor="ctr"/>
-          <a:lstStyle/>
-          <a:p>
-            <a:pPr algn="ctr"/>
-          </a:p>
-        </p:txBody>
-      </p:sp>
-      <p:sp>
-        <p:nvSpPr>
-          <p:cNvPr id="28" name="TextBox 27"/>
-          <p:cNvSpPr txBox="1"/>
-          <p:nvPr/>
-        </p:nvSpPr>
-        <p:spPr>
-          <a:xfrm>
-            <a:off x="8531352" y="4288536"/>
-            <a:ext cx="2871216" cy="905256"/>
-          </a:xfrm>
-          <a:prstGeom prst="rect">
-            <a:avLst/>
-          </a:prstGeom>
-          <a:noFill/>
-        </p:spPr>
-        <p:txBody>
-          <a:bodyPr wrap="square" anchor="t" lIns="0" rIns="0" tIns="0" bIns="0">
-            <a:spAutoFit/>
-          </a:bodyPr>
-          <a:lstStyle/>
-          <a:p>
-            <a:pPr algn="l">
-              <a:lnSpc>
-                <a:spcPct val="105000"/>
-              </a:lnSpc>
-            </a:pPr>
-            <a:r>
-              <a:rPr sz="3000" b="1" i="0">
-                <a:solidFill>
-                  <a:srgbClr val="E3B62C"/>
-                </a:solidFill>
-                <a:latin typeface="Georgia"/>
-              </a:rPr>
-              <a:t>+33 000</a:t>
-            </a:r>
-          </a:p>
-          <a:p>
-            <a:pPr algn="l">
-              <a:lnSpc>
-                <a:spcPct val="105000"/>
-              </a:lnSpc>
-            </a:pPr>
-            <a:r>
-              <a:rPr sz="1250" b="1" i="0">
-                <a:solidFill>
-                  <a:srgbClr val="FFFDF6"/>
-                </a:solidFill>
-                <a:latin typeface="Arial"/>
-              </a:rPr>
-              <a:t>новых соседей ресторана за 5 лет</a:t>
-            </a:r>
-          </a:p>
-          <a:p>
-            <a:pPr algn="l">
-              <a:lnSpc>
-                <a:spcPct val="105000"/>
-              </a:lnSpc>
-            </a:pPr>
-            <a:r>
-              <a:rPr sz="1050" b="0" i="0">
-                <a:solidFill>
-                  <a:srgbClr val="9B9786"/>
-                </a:solidFill>
-                <a:latin typeface="Arial"/>
-              </a:rPr>
-              <a:t>только в радиусе 2 миль</a:t>
-            </a:r>
-          </a:p>
-        </p:txBody>
-      </p:sp>
-      <p:sp>
-        <p:nvSpPr>
-          <p:cNvPr id="29" name="TextBox 28"/>
+              <a:t>+7,6% к 2030 году</a:t>
+            </a:r>
+          </a:p>
+        </p:txBody>
+      </p:sp>
+      <p:sp>
+        <p:nvSpPr>
+          <p:cNvPr id="17" name="TextBox 16"/>
           <p:cNvSpPr txBox="1"/>
           <p:nvPr/>
         </p:nvSpPr>
@@ -4355,7 +3852,7 @@
       </p:sp>
       <p:sp>
         <p:nvSpPr>
-          <p:cNvPr id="30" name="TextBox 29"/>
+          <p:cNvPr id="18" name="TextBox 17"/>
           <p:cNvSpPr txBox="1"/>
           <p:nvPr/>
         </p:nvSpPr>
@@ -4536,7 +4033,7 @@
                 </a:solidFill>
                 <a:latin typeface="Georgia"/>
               </a:rPr>
-              <a:t>средний класс с доходом</a:t>
+              <a:t>1,3 млн человек с доходом</a:t>
             </a:r>
           </a:p>
         </p:txBody>
@@ -4575,7 +4072,7 @@
                 </a:solidFill>
                 <a:latin typeface="Arial"/>
               </a:rPr>
-              <a:t>Доходы, возраст и жильё вокруг Young Circle (CoStar, 2025)</a:t>
+              <a:t>Радиус 10 миль от Young Circle — CoStar, 2025</a:t>
             </a:r>
           </a:p>
         </p:txBody>
@@ -4652,49 +4149,55 @@
           <a:p>
             <a:pPr algn="l">
               <a:lnSpc>
-                <a:spcPct val="105000"/>
+                <a:spcPct val="100000"/>
+              </a:lnSpc>
+              <a:spcAft>
+                <a:spcPts val="800"/>
+              </a:spcAft>
+            </a:pPr>
+            <a:r>
+              <a:rPr sz="2800" b="1" i="0">
+                <a:solidFill>
+                  <a:srgbClr val="E3B62C"/>
+                </a:solidFill>
+                <a:latin typeface="Georgia"/>
+              </a:rPr>
+              <a:t>$71 363</a:t>
+            </a:r>
+          </a:p>
+          <a:p>
+            <a:pPr algn="l">
+              <a:lnSpc>
+                <a:spcPct val="100000"/>
+              </a:lnSpc>
+              <a:spcAft>
+                <a:spcPts val="300"/>
+              </a:spcAft>
+            </a:pPr>
+            <a:r>
+              <a:rPr sz="1250" b="1" i="0">
+                <a:solidFill>
+                  <a:srgbClr val="FFFDF6"/>
+                </a:solidFill>
+                <a:latin typeface="Arial"/>
+              </a:rPr>
+              <a:t>медианный доход домохозяйства</a:t>
+            </a:r>
+          </a:p>
+          <a:p>
+            <a:pPr algn="l">
+              <a:lnSpc>
+                <a:spcPct val="100000"/>
               </a:lnSpc>
             </a:pPr>
             <a:r>
-              <a:rPr sz="3000" b="1" i="0">
-                <a:solidFill>
-                  <a:srgbClr val="E3B62C"/>
-                </a:solidFill>
-                <a:latin typeface="Georgia"/>
-              </a:rPr>
-              <a:t>$60 099</a:t>
-            </a:r>
-          </a:p>
-          <a:p>
-            <a:pPr algn="l">
-              <a:lnSpc>
-                <a:spcPct val="105000"/>
-              </a:lnSpc>
-            </a:pPr>
-            <a:r>
-              <a:rPr sz="1250" b="1" i="0">
-                <a:solidFill>
-                  <a:srgbClr val="FFFDF6"/>
+              <a:rPr sz="1050" b="0" i="0">
+                <a:solidFill>
+                  <a:srgbClr val="9B9786"/>
                 </a:solidFill>
                 <a:latin typeface="Arial"/>
               </a:rPr>
-              <a:t>медианный доход домохозяйства</a:t>
-            </a:r>
-          </a:p>
-          <a:p>
-            <a:pPr algn="l">
-              <a:lnSpc>
-                <a:spcPct val="105000"/>
-              </a:lnSpc>
-            </a:pPr>
-            <a:r>
-              <a:rPr sz="1050" b="0" i="0">
-                <a:solidFill>
-                  <a:srgbClr val="9B9786"/>
-                </a:solidFill>
-                <a:latin typeface="Arial"/>
-              </a:rPr>
-              <a:t>радиус 2 мили от ресторана</a:t>
+              <a:t>выше среднего по стране</a:t>
             </a:r>
           </a:p>
         </p:txBody>
@@ -4771,49 +4274,55 @@
           <a:p>
             <a:pPr algn="l">
               <a:lnSpc>
-                <a:spcPct val="105000"/>
+                <a:spcPct val="100000"/>
+              </a:lnSpc>
+              <a:spcAft>
+                <a:spcPts val="800"/>
+              </a:spcAft>
+            </a:pPr>
+            <a:r>
+              <a:rPr sz="2800" b="1" i="0">
+                <a:solidFill>
+                  <a:srgbClr val="E3B62C"/>
+                </a:solidFill>
+                <a:latin typeface="Georgia"/>
+              </a:rPr>
+              <a:t>$451 881</a:t>
+            </a:r>
+          </a:p>
+          <a:p>
+            <a:pPr algn="l">
+              <a:lnSpc>
+                <a:spcPct val="100000"/>
+              </a:lnSpc>
+              <a:spcAft>
+                <a:spcPts val="300"/>
+              </a:spcAft>
+            </a:pPr>
+            <a:r>
+              <a:rPr sz="1250" b="1" i="0">
+                <a:solidFill>
+                  <a:srgbClr val="FFFDF6"/>
+                </a:solidFill>
+                <a:latin typeface="Arial"/>
+              </a:rPr>
+              <a:t>медианная стоимость жилья</a:t>
+            </a:r>
+          </a:p>
+          <a:p>
+            <a:pPr algn="l">
+              <a:lnSpc>
+                <a:spcPct val="100000"/>
               </a:lnSpc>
             </a:pPr>
             <a:r>
-              <a:rPr sz="3000" b="1" i="0">
-                <a:solidFill>
-                  <a:srgbClr val="E3B62C"/>
-                </a:solidFill>
-                <a:latin typeface="Georgia"/>
-              </a:rPr>
-              <a:t>$67 691</a:t>
-            </a:r>
-          </a:p>
-          <a:p>
-            <a:pPr algn="l">
-              <a:lnSpc>
-                <a:spcPct val="105000"/>
-              </a:lnSpc>
-            </a:pPr>
-            <a:r>
-              <a:rPr sz="1250" b="1" i="0">
-                <a:solidFill>
-                  <a:srgbClr val="FFFDF6"/>
+              <a:rPr sz="1050" b="0" i="0">
+                <a:solidFill>
+                  <a:srgbClr val="9B9786"/>
                 </a:solidFill>
                 <a:latin typeface="Arial"/>
               </a:rPr>
-              <a:t>медианный доход домохозяйства</a:t>
-            </a:r>
-          </a:p>
-          <a:p>
-            <a:pPr algn="l">
-              <a:lnSpc>
-                <a:spcPct val="105000"/>
-              </a:lnSpc>
-            </a:pPr>
-            <a:r>
-              <a:rPr sz="1050" b="0" i="0">
-                <a:solidFill>
-                  <a:srgbClr val="9B9786"/>
-                </a:solidFill>
-                <a:latin typeface="Arial"/>
-              </a:rPr>
-              <a:t>радиус 5 миль</a:t>
+              <a:t>владельцы домов — аудитория ресторана</a:t>
             </a:r>
           </a:p>
         </p:txBody>
@@ -4890,49 +4399,55 @@
           <a:p>
             <a:pPr algn="l">
               <a:lnSpc>
-                <a:spcPct val="105000"/>
+                <a:spcPct val="100000"/>
+              </a:lnSpc>
+              <a:spcAft>
+                <a:spcPts val="800"/>
+              </a:spcAft>
+            </a:pPr>
+            <a:r>
+              <a:rPr sz="2800" b="1" i="0">
+                <a:solidFill>
+                  <a:srgbClr val="E3B62C"/>
+                </a:solidFill>
+                <a:latin typeface="Georgia"/>
+              </a:rPr>
+              <a:t>41 год</a:t>
+            </a:r>
+          </a:p>
+          <a:p>
+            <a:pPr algn="l">
+              <a:lnSpc>
+                <a:spcPct val="100000"/>
+              </a:lnSpc>
+              <a:spcAft>
+                <a:spcPts val="300"/>
+              </a:spcAft>
+            </a:pPr>
+            <a:r>
+              <a:rPr sz="1250" b="1" i="0">
+                <a:solidFill>
+                  <a:srgbClr val="FFFDF6"/>
+                </a:solidFill>
+                <a:latin typeface="Arial"/>
+              </a:rPr>
+              <a:t>средний возраст жителей</a:t>
+            </a:r>
+          </a:p>
+          <a:p>
+            <a:pPr algn="l">
+              <a:lnSpc>
+                <a:spcPct val="100000"/>
               </a:lnSpc>
             </a:pPr>
             <a:r>
-              <a:rPr sz="3000" b="1" i="0">
-                <a:solidFill>
-                  <a:srgbClr val="E3B62C"/>
-                </a:solidFill>
-                <a:latin typeface="Georgia"/>
-              </a:rPr>
-              <a:t>$71 363</a:t>
-            </a:r>
-          </a:p>
-          <a:p>
-            <a:pPr algn="l">
-              <a:lnSpc>
-                <a:spcPct val="105000"/>
-              </a:lnSpc>
-            </a:pPr>
-            <a:r>
-              <a:rPr sz="1250" b="1" i="0">
-                <a:solidFill>
-                  <a:srgbClr val="FFFDF6"/>
+              <a:rPr sz="1050" b="0" i="0">
+                <a:solidFill>
+                  <a:srgbClr val="9B9786"/>
                 </a:solidFill>
                 <a:latin typeface="Arial"/>
               </a:rPr>
-              <a:t>медианный доход домохозяйства</a:t>
-            </a:r>
-          </a:p>
-          <a:p>
-            <a:pPr algn="l">
-              <a:lnSpc>
-                <a:spcPct val="105000"/>
-              </a:lnSpc>
-            </a:pPr>
-            <a:r>
-              <a:rPr sz="1050" b="0" i="0">
-                <a:solidFill>
-                  <a:srgbClr val="9B9786"/>
-                </a:solidFill>
-                <a:latin typeface="Arial"/>
-              </a:rPr>
-              <a:t>радиус 10 миль</a:t>
+              <a:t>активная платёжеспособная аудитория</a:t>
             </a:r>
           </a:p>
         </p:txBody>
@@ -5009,49 +4524,55 @@
           <a:p>
             <a:pPr algn="l">
               <a:lnSpc>
-                <a:spcPct val="105000"/>
+                <a:spcPct val="100000"/>
+              </a:lnSpc>
+              <a:spcAft>
+                <a:spcPts val="800"/>
+              </a:spcAft>
+            </a:pPr>
+            <a:r>
+              <a:rPr sz="2800" b="1" i="0">
+                <a:solidFill>
+                  <a:srgbClr val="E3B62C"/>
+                </a:solidFill>
+                <a:latin typeface="Georgia"/>
+              </a:rPr>
+              <a:t>2,5</a:t>
+            </a:r>
+          </a:p>
+          <a:p>
+            <a:pPr algn="l">
+              <a:lnSpc>
+                <a:spcPct val="100000"/>
+              </a:lnSpc>
+              <a:spcAft>
+                <a:spcPts val="300"/>
+              </a:spcAft>
+            </a:pPr>
+            <a:r>
+              <a:rPr sz="1250" b="1" i="0">
+                <a:solidFill>
+                  <a:srgbClr val="FFFDF6"/>
+                </a:solidFill>
+                <a:latin typeface="Arial"/>
+              </a:rPr>
+              <a:t>человека в среднем домохозяйстве</a:t>
+            </a:r>
+          </a:p>
+          <a:p>
+            <a:pPr algn="l">
+              <a:lnSpc>
+                <a:spcPct val="100000"/>
               </a:lnSpc>
             </a:pPr>
             <a:r>
-              <a:rPr sz="3000" b="1" i="0">
-                <a:solidFill>
-                  <a:srgbClr val="E3B62C"/>
-                </a:solidFill>
-                <a:latin typeface="Georgia"/>
-              </a:rPr>
-              <a:t>42 253 → 45 179</a:t>
-            </a:r>
-          </a:p>
-          <a:p>
-            <a:pPr algn="l">
-              <a:lnSpc>
-                <a:spcPct val="105000"/>
-              </a:lnSpc>
-            </a:pPr>
-            <a:r>
-              <a:rPr sz="1250" b="1" i="0">
-                <a:solidFill>
-                  <a:srgbClr val="FFFDF6"/>
+              <a:rPr sz="1050" b="0" i="0">
+                <a:solidFill>
+                  <a:srgbClr val="9B9786"/>
                 </a:solidFill>
                 <a:latin typeface="Arial"/>
               </a:rPr>
-              <a:t>домохозяйств в 2 милях</a:t>
-            </a:r>
-          </a:p>
-          <a:p>
-            <a:pPr algn="l">
-              <a:lnSpc>
-                <a:spcPct val="105000"/>
-              </a:lnSpc>
-            </a:pPr>
-            <a:r>
-              <a:rPr sz="1050" b="0" i="0">
-                <a:solidFill>
-                  <a:srgbClr val="9B9786"/>
-                </a:solidFill>
-                <a:latin typeface="Arial"/>
-              </a:rPr>
-              <a:t>+6,9% к 2030 году</a:t>
+              <a:t>семейный формат посещений</a:t>
             </a:r>
           </a:p>
         </p:txBody>
@@ -5128,49 +4649,55 @@
           <a:p>
             <a:pPr algn="l">
               <a:lnSpc>
-                <a:spcPct val="105000"/>
+                <a:spcPct val="100000"/>
+              </a:lnSpc>
+              <a:spcAft>
+                <a:spcPts val="800"/>
+              </a:spcAft>
+            </a:pPr>
+            <a:r>
+              <a:rPr sz="2800" b="1" i="0">
+                <a:solidFill>
+                  <a:srgbClr val="E3B62C"/>
+                </a:solidFill>
+                <a:latin typeface="Georgia"/>
+              </a:rPr>
+              <a:t>463 898</a:t>
+            </a:r>
+          </a:p>
+          <a:p>
+            <a:pPr algn="l">
+              <a:lnSpc>
+                <a:spcPct val="100000"/>
+              </a:lnSpc>
+              <a:spcAft>
+                <a:spcPts val="300"/>
+              </a:spcAft>
+            </a:pPr>
+            <a:r>
+              <a:rPr sz="1250" b="1" i="0">
+                <a:solidFill>
+                  <a:srgbClr val="FFFDF6"/>
+                </a:solidFill>
+                <a:latin typeface="Arial"/>
+              </a:rPr>
+              <a:t>домохозяйств в радиусе 10 миль</a:t>
+            </a:r>
+          </a:p>
+          <a:p>
+            <a:pPr algn="l">
+              <a:lnSpc>
+                <a:spcPct val="100000"/>
               </a:lnSpc>
             </a:pPr>
             <a:r>
-              <a:rPr sz="3000" b="1" i="0">
-                <a:solidFill>
-                  <a:srgbClr val="E3B62C"/>
-                </a:solidFill>
-                <a:latin typeface="Georgia"/>
-              </a:rPr>
-              <a:t>$443 846</a:t>
-            </a:r>
-          </a:p>
-          <a:p>
-            <a:pPr algn="l">
-              <a:lnSpc>
-                <a:spcPct val="105000"/>
-              </a:lnSpc>
-            </a:pPr>
-            <a:r>
-              <a:rPr sz="1250" b="1" i="0">
-                <a:solidFill>
-                  <a:srgbClr val="FFFDF6"/>
+              <a:rPr sz="1050" b="0" i="0">
+                <a:solidFill>
+                  <a:srgbClr val="9B9786"/>
                 </a:solidFill>
                 <a:latin typeface="Arial"/>
               </a:rPr>
-              <a:t>медианная стоимость жилья</a:t>
-            </a:r>
-          </a:p>
-          <a:p>
-            <a:pPr algn="l">
-              <a:lnSpc>
-                <a:spcPct val="105000"/>
-              </a:lnSpc>
-            </a:pPr>
-            <a:r>
-              <a:rPr sz="1050" b="0" i="0">
-                <a:solidFill>
-                  <a:srgbClr val="9B9786"/>
-                </a:solidFill>
-                <a:latin typeface="Arial"/>
-              </a:rPr>
-              <a:t>владельцы домов — аудитория ресторана</a:t>
+              <a:t>+7,6% к 2030 году</a:t>
             </a:r>
           </a:p>
         </p:txBody>
@@ -5247,49 +4774,55 @@
           <a:p>
             <a:pPr algn="l">
               <a:lnSpc>
-                <a:spcPct val="105000"/>
+                <a:spcPct val="100000"/>
+              </a:lnSpc>
+              <a:spcAft>
+                <a:spcPts val="800"/>
+              </a:spcAft>
+            </a:pPr>
+            <a:r>
+              <a:rPr sz="2800" b="1" i="0">
+                <a:solidFill>
+                  <a:srgbClr val="E3B62C"/>
+                </a:solidFill>
+                <a:latin typeface="Georgia"/>
+              </a:rPr>
+              <a:t>920 000</a:t>
+            </a:r>
+          </a:p>
+          <a:p>
+            <a:pPr algn="l">
+              <a:lnSpc>
+                <a:spcPct val="100000"/>
+              </a:lnSpc>
+              <a:spcAft>
+                <a:spcPts val="300"/>
+              </a:spcAft>
+            </a:pPr>
+            <a:r>
+              <a:rPr sz="1250" b="1" i="0">
+                <a:solidFill>
+                  <a:srgbClr val="FFFDF6"/>
+                </a:solidFill>
+                <a:latin typeface="Arial"/>
+              </a:rPr>
+              <a:t>рабочих мест в рынке Ft. Lauderdale</a:t>
+            </a:r>
+          </a:p>
+          <a:p>
+            <a:pPr algn="l">
+              <a:lnSpc>
+                <a:spcPct val="100000"/>
               </a:lnSpc>
             </a:pPr>
             <a:r>
-              <a:rPr sz="3000" b="1" i="0">
-                <a:solidFill>
-                  <a:srgbClr val="E3B62C"/>
-                </a:solidFill>
-                <a:latin typeface="Georgia"/>
-              </a:rPr>
-              <a:t>44 года</a:t>
-            </a:r>
-          </a:p>
-          <a:p>
-            <a:pPr algn="l">
-              <a:lnSpc>
-                <a:spcPct val="105000"/>
-              </a:lnSpc>
-            </a:pPr>
-            <a:r>
-              <a:rPr sz="1250" b="1" i="0">
-                <a:solidFill>
-                  <a:srgbClr val="FFFDF6"/>
+              <a:rPr sz="1050" b="0" i="0">
+                <a:solidFill>
+                  <a:srgbClr val="9B9786"/>
                 </a:solidFill>
                 <a:latin typeface="Arial"/>
               </a:rPr>
-              <a:t>средний возраст жителей</a:t>
-            </a:r>
-          </a:p>
-          <a:p>
-            <a:pPr algn="l">
-              <a:lnSpc>
-                <a:spcPct val="105000"/>
-              </a:lnSpc>
-            </a:pPr>
-            <a:r>
-              <a:rPr sz="1050" b="0" i="0">
-                <a:solidFill>
-                  <a:srgbClr val="9B9786"/>
-                </a:solidFill>
-                <a:latin typeface="Arial"/>
-              </a:rPr>
-              <a:t>стабильная взрослая клиентская база</a:t>
+              <a:t>поток гостей на ланч и ужин</a:t>
             </a:r>
           </a:p>
         </p:txBody>
@@ -5632,11 +5165,14 @@
           <a:p>
             <a:pPr algn="l">
               <a:lnSpc>
-                <a:spcPct val="105000"/>
+                <a:spcPct val="100000"/>
               </a:lnSpc>
+              <a:spcAft>
+                <a:spcPts val="800"/>
+              </a:spcAft>
             </a:pPr>
             <a:r>
-              <a:rPr sz="3000" b="1" i="0">
+              <a:rPr sz="2800" b="1" i="0">
                 <a:solidFill>
                   <a:srgbClr val="E3B62C"/>
                 </a:solidFill>
@@ -5648,8 +5184,11 @@
           <a:p>
             <a:pPr algn="l">
               <a:lnSpc>
-                <a:spcPct val="105000"/>
+                <a:spcPct val="100000"/>
               </a:lnSpc>
+              <a:spcAft>
+                <a:spcPts val="300"/>
+              </a:spcAft>
             </a:pPr>
             <a:r>
               <a:rPr sz="1250" b="1" i="0">
@@ -5664,7 +5203,7 @@
           <a:p>
             <a:pPr algn="l">
               <a:lnSpc>
-                <a:spcPct val="105000"/>
+                <a:spcPct val="100000"/>
               </a:lnSpc>
             </a:pPr>
             <a:r>
@@ -5751,11 +5290,14 @@
           <a:p>
             <a:pPr algn="l">
               <a:lnSpc>
-                <a:spcPct val="105000"/>
+                <a:spcPct val="100000"/>
               </a:lnSpc>
+              <a:spcAft>
+                <a:spcPts val="800"/>
+              </a:spcAft>
             </a:pPr>
             <a:r>
-              <a:rPr sz="3000" b="1" i="0">
+              <a:rPr sz="2800" b="1" i="0">
                 <a:solidFill>
                   <a:srgbClr val="E3B62C"/>
                 </a:solidFill>
@@ -5767,8 +5309,11 @@
           <a:p>
             <a:pPr algn="l">
               <a:lnSpc>
-                <a:spcPct val="105000"/>
+                <a:spcPct val="100000"/>
               </a:lnSpc>
+              <a:spcAft>
+                <a:spcPts val="300"/>
+              </a:spcAft>
             </a:pPr>
             <a:r>
               <a:rPr sz="1250" b="1" i="0">
@@ -5783,7 +5328,7 @@
           <a:p>
             <a:pPr algn="l">
               <a:lnSpc>
-                <a:spcPct val="105000"/>
+                <a:spcPct val="100000"/>
               </a:lnSpc>
             </a:pPr>
             <a:r>
@@ -5870,11 +5415,14 @@
           <a:p>
             <a:pPr algn="l">
               <a:lnSpc>
-                <a:spcPct val="105000"/>
+                <a:spcPct val="100000"/>
               </a:lnSpc>
+              <a:spcAft>
+                <a:spcPts val="800"/>
+              </a:spcAft>
             </a:pPr>
             <a:r>
-              <a:rPr sz="3000" b="1" i="0">
+              <a:rPr sz="2800" b="1" i="0">
                 <a:solidFill>
                   <a:srgbClr val="E3B62C"/>
                 </a:solidFill>
@@ -5886,8 +5434,11 @@
           <a:p>
             <a:pPr algn="l">
               <a:lnSpc>
-                <a:spcPct val="105000"/>
+                <a:spcPct val="100000"/>
               </a:lnSpc>
+              <a:spcAft>
+                <a:spcPts val="300"/>
+              </a:spcAft>
             </a:pPr>
             <a:r>
               <a:rPr sz="1250" b="1" i="0">
@@ -5902,7 +5453,7 @@
           <a:p>
             <a:pPr algn="l">
               <a:lnSpc>
-                <a:spcPct val="105000"/>
+                <a:spcPct val="100000"/>
               </a:lnSpc>
             </a:pPr>
             <a:r>
@@ -5989,11 +5540,14 @@
           <a:p>
             <a:pPr algn="l">
               <a:lnSpc>
-                <a:spcPct val="105000"/>
+                <a:spcPct val="100000"/>
               </a:lnSpc>
+              <a:spcAft>
+                <a:spcPts val="800"/>
+              </a:spcAft>
             </a:pPr>
             <a:r>
-              <a:rPr sz="3000" b="1" i="0">
+              <a:rPr sz="2800" b="1" i="0">
                 <a:solidFill>
                   <a:srgbClr val="E3B62C"/>
                 </a:solidFill>
@@ -6005,8 +5559,11 @@
           <a:p>
             <a:pPr algn="l">
               <a:lnSpc>
-                <a:spcPct val="105000"/>
+                <a:spcPct val="100000"/>
               </a:lnSpc>
+              <a:spcAft>
+                <a:spcPts val="300"/>
+              </a:spcAft>
             </a:pPr>
             <a:r>
               <a:rPr sz="1250" b="1" i="0">
@@ -6021,7 +5578,7 @@
           <a:p>
             <a:pPr algn="l">
               <a:lnSpc>
-                <a:spcPct val="105000"/>
+                <a:spcPct val="100000"/>
               </a:lnSpc>
             </a:pPr>
             <a:r>
@@ -6108,11 +5665,14 @@
           <a:p>
             <a:pPr algn="l">
               <a:lnSpc>
-                <a:spcPct val="105000"/>
+                <a:spcPct val="100000"/>
               </a:lnSpc>
+              <a:spcAft>
+                <a:spcPts val="800"/>
+              </a:spcAft>
             </a:pPr>
             <a:r>
-              <a:rPr sz="3000" b="1" i="0">
+              <a:rPr sz="2800" b="1" i="0">
                 <a:solidFill>
                   <a:srgbClr val="E3B62C"/>
                 </a:solidFill>
@@ -6124,8 +5684,11 @@
           <a:p>
             <a:pPr algn="l">
               <a:lnSpc>
-                <a:spcPct val="105000"/>
+                <a:spcPct val="100000"/>
               </a:lnSpc>
+              <a:spcAft>
+                <a:spcPts val="300"/>
+              </a:spcAft>
             </a:pPr>
             <a:r>
               <a:rPr sz="1250" b="1" i="0">
@@ -6140,7 +5703,7 @@
           <a:p>
             <a:pPr algn="l">
               <a:lnSpc>
-                <a:spcPct val="105000"/>
+                <a:spcPct val="100000"/>
               </a:lnSpc>
             </a:pPr>
             <a:r>
@@ -6227,11 +5790,14 @@
           <a:p>
             <a:pPr algn="l">
               <a:lnSpc>
-                <a:spcPct val="105000"/>
+                <a:spcPct val="100000"/>
               </a:lnSpc>
+              <a:spcAft>
+                <a:spcPts val="800"/>
+              </a:spcAft>
             </a:pPr>
             <a:r>
-              <a:rPr sz="3000" b="1" i="0">
+              <a:rPr sz="2800" b="1" i="0">
                 <a:solidFill>
                   <a:srgbClr val="E3B62C"/>
                 </a:solidFill>
@@ -6243,8 +5809,11 @@
           <a:p>
             <a:pPr algn="l">
               <a:lnSpc>
-                <a:spcPct val="105000"/>
+                <a:spcPct val="100000"/>
               </a:lnSpc>
+              <a:spcAft>
+                <a:spcPts val="300"/>
+              </a:spcAft>
             </a:pPr>
             <a:r>
               <a:rPr sz="1250" b="1" i="0">
@@ -6259,7 +5828,7 @@
           <a:p>
             <a:pPr algn="l">
               <a:lnSpc>
-                <a:spcPct val="105000"/>
+                <a:spcPct val="100000"/>
               </a:lnSpc>
             </a:pPr>
             <a:r>

</xml_diff>